<commit_message>
Add kinetic shift slide and expand reticulocyte spike explanations
- Add slide 5 "Décalage cinétique PK → Hématotoxicité" with pk_hema_shift.png,
  explaining temporal dissociation between Cmax and hematological nadir and
  why a direct Emax model would be inadequate
- Update slide 4 with 5 detailed reasons for reticulocyte spikes (compensatory
  reticulocytosis, handling stress, phlebotomy response, NHP biological variability,
  independence from the compound)
- Renumber slides 5→6 (PD projections), 6→7 (next steps), 7→8 (synthesis)
- PowerPoint now has 8 slides total

https://claude.ai/code/session_01Xq7iVQ2YjVtBT1RakGGhea
</commit_message>
<xml_diff>
--- a/FGFR2_NHP_resultats.pptx
+++ b/FGFR2_NHP_resultats.pptx
@@ -12,6 +12,7 @@
     <p:sldId id="260" r:id="rId11"/>
     <p:sldId id="261" r:id="rId12"/>
     <p:sldId id="262" r:id="rId13"/>
+    <p:sldId id="263" r:id="rId14"/>
   </p:sldIdLst>
   <p:sldSz cx="12188952" cy="6858000" type="screen4x3"/>
   <p:notesSz cx="6858000" cy="9144000"/>
@@ -7031,8 +7032,8 @@
         </p:nvSpPr>
         <p:spPr>
           <a:xfrm>
-            <a:off x="9144000" y="1645920"/>
-            <a:ext cx="2651760" cy="1051560"/>
+            <a:off x="9144000" y="1627632"/>
+            <a:ext cx="2651760" cy="960120"/>
           </a:xfrm>
           <a:prstGeom prst="rect">
             <a:avLst/>
@@ -7067,8 +7068,8 @@
         </p:nvSpPr>
         <p:spPr>
           <a:xfrm>
-            <a:off x="9144000" y="2651760"/>
-            <a:ext cx="2651760" cy="1051560"/>
+            <a:off x="9144000" y="2542032"/>
+            <a:ext cx="2651760" cy="960120"/>
           </a:xfrm>
           <a:prstGeom prst="rect">
             <a:avLst/>
@@ -7089,8 +7090,8 @@
                 </a:solidFill>
               </a:rPr>
               <a:t>▸ ✓ RBC &amp; Plaquettes :
-suppression modérée
-bien reproduite</a:t>
+suppression bien
+reproduites</a:t>
             </a:r>
           </a:p>
         </p:txBody>
@@ -7103,8 +7104,8 @@
         </p:nvSpPr>
         <p:spPr>
           <a:xfrm>
-            <a:off x="9144000" y="3657600"/>
-            <a:ext cx="2651760" cy="1051560"/>
+            <a:off x="9144000" y="3566160"/>
+            <a:ext cx="2651760" cy="347472"/>
           </a:xfrm>
           <a:prstGeom prst="rect">
             <a:avLst/>
@@ -7119,28 +7120,61 @@
           <a:p>
             <a:pPr algn="l"/>
             <a:r>
-              <a:rPr sz="1100" b="0" i="0">
+              <a:rPr sz="1200" b="1" i="0">
+                <a:solidFill>
+                  <a:srgbClr val="C5501A"/>
+                </a:solidFill>
+              </a:rPr>
+              <a:t>⚠ Pics réticulocytes (D2–D8)</a:t>
+            </a:r>
+          </a:p>
+        </p:txBody>
+      </p:sp>
+      <p:sp>
+        <p:nvSpPr>
+          <p:cNvPr id="14" name="TextBox 13"/>
+          <p:cNvSpPr txBox="1"/>
+          <p:nvPr/>
+        </p:nvSpPr>
+        <p:spPr>
+          <a:xfrm>
+            <a:off x="9144000" y="3913632"/>
+            <a:ext cx="2651760" cy="502920"/>
+          </a:xfrm>
+          <a:prstGeom prst="rect">
+            <a:avLst/>
+          </a:prstGeom>
+          <a:noFill/>
+        </p:spPr>
+        <p:txBody>
+          <a:bodyPr wrap="square">
+            <a:spAutoFit/>
+          </a:bodyPr>
+          <a:lstStyle/>
+          <a:p>
+            <a:pPr algn="l"/>
+            <a:r>
+              <a:rPr sz="1100" b="0" i="1">
                 <a:solidFill>
                   <a:srgbClr val="1A1A1A"/>
                 </a:solidFill>
               </a:rPr>
-              <a:t>▸ ⚠ Réticulocytes :
-pics D2–D8 non
-captés par le modèle</a:t>
-            </a:r>
-          </a:p>
-        </p:txBody>
-      </p:sp>
-      <p:sp>
-        <p:nvSpPr>
-          <p:cNvPr id="14" name="TextBox 13"/>
-          <p:cNvSpPr txBox="1"/>
-          <p:nvPr/>
-        </p:nvSpPr>
-        <p:spPr>
-          <a:xfrm>
-            <a:off x="9144000" y="4663440"/>
-            <a:ext cx="2651760" cy="1051560"/>
+              <a:t>Non captés par le modèle
+→ facteurs extérieurs :</a:t>
+            </a:r>
+          </a:p>
+        </p:txBody>
+      </p:sp>
+      <p:sp>
+        <p:nvSpPr>
+          <p:cNvPr id="15" name="TextBox 14"/>
+          <p:cNvSpPr txBox="1"/>
+          <p:nvPr/>
+        </p:nvSpPr>
+        <p:spPr>
+          <a:xfrm>
+            <a:off x="9144000" y="4434840"/>
+            <a:ext cx="2651760" cy="429768"/>
           </a:xfrm>
           <a:prstGeom prst="rect">
             <a:avLst/>
@@ -7155,15 +7189,153 @@
           <a:p>
             <a:pPr algn="l"/>
             <a:r>
-              <a:rPr sz="1100" b="0" i="0">
+              <a:rPr sz="1000" b="0" i="0">
                 <a:solidFill>
                   <a:srgbClr val="1A1A1A"/>
                 </a:solidFill>
               </a:rPr>
-              <a:t>→ Ces pics résultent
-de facteurs extérieurs
-(état préexistant,
-stress de manipulation)</a:t>
+              <a:t>▸ Anémie préexistante
+(réticulocytose compensatoire)</a:t>
+            </a:r>
+          </a:p>
+        </p:txBody>
+      </p:sp>
+      <p:sp>
+        <p:nvSpPr>
+          <p:cNvPr id="16" name="TextBox 15"/>
+          <p:cNvSpPr txBox="1"/>
+          <p:nvPr/>
+        </p:nvSpPr>
+        <p:spPr>
+          <a:xfrm>
+            <a:off x="9144000" y="4818888"/>
+            <a:ext cx="2651760" cy="429768"/>
+          </a:xfrm>
+          <a:prstGeom prst="rect">
+            <a:avLst/>
+          </a:prstGeom>
+          <a:noFill/>
+        </p:spPr>
+        <p:txBody>
+          <a:bodyPr wrap="square">
+            <a:spAutoFit/>
+          </a:bodyPr>
+          <a:lstStyle/>
+          <a:p>
+            <a:pPr algn="l"/>
+            <a:r>
+              <a:rPr sz="1000" b="0" i="0">
+                <a:solidFill>
+                  <a:srgbClr val="1A1A1A"/>
+                </a:solidFill>
+              </a:rPr>
+              <a:t>▸ Stress de contention /
+manipulation des animaux</a:t>
+            </a:r>
+          </a:p>
+        </p:txBody>
+      </p:sp>
+      <p:sp>
+        <p:nvSpPr>
+          <p:cNvPr id="17" name="TextBox 16"/>
+          <p:cNvSpPr txBox="1"/>
+          <p:nvPr/>
+        </p:nvSpPr>
+        <p:spPr>
+          <a:xfrm>
+            <a:off x="9144000" y="5202936"/>
+            <a:ext cx="2651760" cy="429768"/>
+          </a:xfrm>
+          <a:prstGeom prst="rect">
+            <a:avLst/>
+          </a:prstGeom>
+          <a:noFill/>
+        </p:spPr>
+        <p:txBody>
+          <a:bodyPr wrap="square">
+            <a:spAutoFit/>
+          </a:bodyPr>
+          <a:lstStyle/>
+          <a:p>
+            <a:pPr algn="l"/>
+            <a:r>
+              <a:rPr sz="1000" b="0" i="0">
+                <a:solidFill>
+                  <a:srgbClr val="1A1A1A"/>
+                </a:solidFill>
+              </a:rPr>
+              <a:t>▸ Réponse à la phlébotomie
+répétée</a:t>
+            </a:r>
+          </a:p>
+        </p:txBody>
+      </p:sp>
+      <p:sp>
+        <p:nvSpPr>
+          <p:cNvPr id="18" name="TextBox 17"/>
+          <p:cNvSpPr txBox="1"/>
+          <p:nvPr/>
+        </p:nvSpPr>
+        <p:spPr>
+          <a:xfrm>
+            <a:off x="9144000" y="5586983"/>
+            <a:ext cx="2651760" cy="429768"/>
+          </a:xfrm>
+          <a:prstGeom prst="rect">
+            <a:avLst/>
+          </a:prstGeom>
+          <a:noFill/>
+        </p:spPr>
+        <p:txBody>
+          <a:bodyPr wrap="square">
+            <a:spAutoFit/>
+          </a:bodyPr>
+          <a:lstStyle/>
+          <a:p>
+            <a:pPr algn="l"/>
+            <a:r>
+              <a:rPr sz="1000" b="0" i="0">
+                <a:solidFill>
+                  <a:srgbClr val="1A1A1A"/>
+                </a:solidFill>
+              </a:rPr>
+              <a:t>▸ Variabilité biologique NHP
+naturellement élevée</a:t>
+            </a:r>
+          </a:p>
+        </p:txBody>
+      </p:sp>
+      <p:sp>
+        <p:nvSpPr>
+          <p:cNvPr id="19" name="TextBox 18"/>
+          <p:cNvSpPr txBox="1"/>
+          <p:nvPr/>
+        </p:nvSpPr>
+        <p:spPr>
+          <a:xfrm>
+            <a:off x="9144000" y="5971031"/>
+            <a:ext cx="2651760" cy="429768"/>
+          </a:xfrm>
+          <a:prstGeom prst="rect">
+            <a:avLst/>
+          </a:prstGeom>
+          <a:noFill/>
+        </p:spPr>
+        <p:txBody>
+          <a:bodyPr wrap="square">
+            <a:spAutoFit/>
+          </a:bodyPr>
+          <a:lstStyle/>
+          <a:p>
+            <a:pPr algn="l"/>
+            <a:r>
+              <a:rPr sz="1000" b="0" i="0">
+                <a:solidFill>
+                  <a:srgbClr val="1A1A1A"/>
+                </a:solidFill>
+              </a:rPr>
+              <a:t>▸ Indépendant du composé
+(survient dès J2)</a:t>
             </a:r>
           </a:p>
         </p:txBody>
@@ -7258,7 +7430,7 @@
                   <a:srgbClr val="FFFFFF"/>
                 </a:solidFill>
               </a:rPr>
-              <a:t>Projections PD — Simulation Q3W × 3 cycles + récupération</a:t>
+              <a:t>Décalage cinétique PK → Hématotoxicité</a:t>
             </a:r>
           </a:p>
         </p:txBody>
@@ -7292,7 +7464,7 @@
                   <a:srgbClr val="D6E4F0"/>
                 </a:solidFill>
               </a:rPr>
-              <a:t>Profils prédits D0–D90 | % de la baseline individuelle | Sans données observées</a:t>
+              <a:t>Dissociation temporelle entre le pic plasmatique et le nadir hématologique</a:t>
             </a:r>
           </a:p>
         </p:txBody>
@@ -7448,7 +7620,7 @@
                   <a:srgbClr val="CCCCCC"/>
                 </a:solidFill>
               </a:rPr>
-              <a:t>[Image : poster_PD_predicted_individual_noobs.png]</a:t>
+              <a:t>[Image : pk_hema_shift.png]</a:t>
             </a:r>
           </a:p>
         </p:txBody>
@@ -7527,7 +7699,7 @@
                   <a:srgbClr val="1A3A5C"/>
                 </a:solidFill>
               </a:rPr>
-              <a:t>Points clés</a:t>
+              <a:t>Message clé</a:t>
             </a:r>
           </a:p>
         </p:txBody>
@@ -7541,7 +7713,7 @@
         <p:spPr>
           <a:xfrm>
             <a:off x="9144000" y="1645920"/>
-            <a:ext cx="2651760" cy="868680"/>
+            <a:ext cx="2651760" cy="960120"/>
           </a:xfrm>
           <a:prstGeom prst="rect">
             <a:avLst/>
@@ -7556,13 +7728,13 @@
           <a:p>
             <a:pPr algn="l"/>
             <a:r>
-              <a:rPr sz="1200" b="0" i="0">
+              <a:rPr sz="1100" b="0" i="0">
                 <a:solidFill>
                   <a:srgbClr val="1A1A1A"/>
                 </a:solidFill>
               </a:rPr>
-              <a:t>▸ Effet cumulatif sur
-3 cycles visible</a:t>
+              <a:t>▸ PK : Cmax atteint
+dès J1 (pic immédiat)</a:t>
             </a:r>
           </a:p>
         </p:txBody>
@@ -7575,8 +7747,8 @@
         </p:nvSpPr>
         <p:spPr>
           <a:xfrm>
-            <a:off x="9144000" y="2468880"/>
-            <a:ext cx="2651760" cy="868680"/>
+            <a:off x="9144000" y="2560320"/>
+            <a:ext cx="2651760" cy="960120"/>
           </a:xfrm>
           <a:prstGeom prst="rect">
             <a:avLst/>
@@ -7591,13 +7763,14 @@
           <a:p>
             <a:pPr algn="l"/>
             <a:r>
-              <a:rPr sz="1200" b="0" i="0">
+              <a:rPr sz="1100" b="0" i="0">
                 <a:solidFill>
                   <a:srgbClr val="1A1A1A"/>
                 </a:solidFill>
               </a:rPr>
-              <a:t>▸ Nadir le plus profond
-après la 3ᵉ dose (J42)</a:t>
+              <a:t>▸ Nadir hématologique :
+décalé de plusieurs jours
+après le Cmax</a:t>
             </a:r>
           </a:p>
         </p:txBody>
@@ -7610,8 +7783,8 @@
         </p:nvSpPr>
         <p:spPr>
           <a:xfrm>
-            <a:off x="9144000" y="3291840"/>
-            <a:ext cx="2651760" cy="868680"/>
+            <a:off x="9144000" y="3474720"/>
+            <a:ext cx="2651760" cy="960120"/>
           </a:xfrm>
           <a:prstGeom prst="rect">
             <a:avLst/>
@@ -7626,13 +7799,14 @@
           <a:p>
             <a:pPr algn="l"/>
             <a:r>
-              <a:rPr sz="1200" b="0" i="0">
+              <a:rPr sz="1100" b="0" i="0">
                 <a:solidFill>
                   <a:srgbClr val="1A1A1A"/>
                 </a:solidFill>
               </a:rPr>
-              <a:t>▸ Récupération partielle
-entre cycles</a:t>
+              <a:t>▸ Ce délai reflète la
+durée de vie des
+précurseurs médullaires</a:t>
             </a:r>
           </a:p>
         </p:txBody>
@@ -7645,8 +7819,8 @@
         </p:nvSpPr>
         <p:spPr>
           <a:xfrm>
-            <a:off x="9144000" y="4114800"/>
-            <a:ext cx="2651760" cy="868680"/>
+            <a:off x="9144000" y="4572000"/>
+            <a:ext cx="2651760" cy="347472"/>
           </a:xfrm>
           <a:prstGeom prst="rect">
             <a:avLst/>
@@ -7661,27 +7835,61 @@
           <a:p>
             <a:pPr algn="l"/>
             <a:r>
-              <a:rPr sz="1200" b="0" i="0">
+              <a:rPr sz="1200" b="1" i="0">
+                <a:solidFill>
+                  <a:srgbClr val="C5501A"/>
+                </a:solidFill>
+              </a:rPr>
+              <a:t>Pourquoi c'est important</a:t>
+            </a:r>
+          </a:p>
+        </p:txBody>
+      </p:sp>
+      <p:sp>
+        <p:nvSpPr>
+          <p:cNvPr id="15" name="TextBox 14"/>
+          <p:cNvSpPr txBox="1"/>
+          <p:nvPr/>
+        </p:nvSpPr>
+        <p:spPr>
+          <a:xfrm>
+            <a:off x="9144000" y="4956048"/>
+            <a:ext cx="2651760" cy="521208"/>
+          </a:xfrm>
+          <a:prstGeom prst="rect">
+            <a:avLst/>
+          </a:prstGeom>
+          <a:noFill/>
+        </p:spPr>
+        <p:txBody>
+          <a:bodyPr wrap="square">
+            <a:spAutoFit/>
+          </a:bodyPr>
+          <a:lstStyle/>
+          <a:p>
+            <a:pPr algn="l"/>
+            <a:r>
+              <a:rPr sz="1000" b="0" i="0">
                 <a:solidFill>
                   <a:srgbClr val="1A1A1A"/>
                 </a:solidFill>
               </a:rPr>
-              <a:t>▸ Dose-réponse claire :
-39 mg/kg &gt; 26 &gt; 13 &gt; 4</a:t>
-            </a:r>
-          </a:p>
-        </p:txBody>
-      </p:sp>
-      <p:sp>
-        <p:nvSpPr>
-          <p:cNvPr id="15" name="TextBox 14"/>
-          <p:cNvSpPr txBox="1"/>
-          <p:nvPr/>
-        </p:nvSpPr>
-        <p:spPr>
-          <a:xfrm>
-            <a:off x="9144000" y="4937760"/>
-            <a:ext cx="2651760" cy="868680"/>
+              <a:t>▸ Un modèle Emax direct
+serait inadapté ici</a:t>
+            </a:r>
+          </a:p>
+        </p:txBody>
+      </p:sp>
+      <p:sp>
+        <p:nvSpPr>
+          <p:cNvPr id="16" name="TextBox 15"/>
+          <p:cNvSpPr txBox="1"/>
+          <p:nvPr/>
+        </p:nvSpPr>
+        <p:spPr>
+          <a:xfrm>
+            <a:off x="9144000" y="5431536"/>
+            <a:ext cx="2651760" cy="521208"/>
           </a:xfrm>
           <a:prstGeom prst="rect">
             <a:avLst/>
@@ -7696,27 +7904,28 @@
           <a:p>
             <a:pPr algn="l"/>
             <a:r>
-              <a:rPr sz="1200" b="0" i="0">
+              <a:rPr sz="1000" b="0" i="0">
                 <a:solidFill>
                   <a:srgbClr val="1A1A1A"/>
                 </a:solidFill>
               </a:rPr>
-              <a:t>▸ Retour à la baseline
-attendu ~J80–D90</a:t>
-            </a:r>
-          </a:p>
-        </p:txBody>
-      </p:sp>
-      <p:sp>
-        <p:nvSpPr>
-          <p:cNvPr id="16" name="TextBox 15"/>
-          <p:cNvSpPr txBox="1"/>
-          <p:nvPr/>
-        </p:nvSpPr>
-        <p:spPr>
-          <a:xfrm>
-            <a:off x="9144000" y="5577840"/>
-            <a:ext cx="2651760" cy="274320"/>
+              <a:t>▸ Le modèle semi-mécaniste
+(Fornari) capture ce
+décalage explicitement</a:t>
+            </a:r>
+          </a:p>
+        </p:txBody>
+      </p:sp>
+      <p:sp>
+        <p:nvSpPr>
+          <p:cNvPr id="17" name="TextBox 16"/>
+          <p:cNvSpPr txBox="1"/>
+          <p:nvPr/>
+        </p:nvSpPr>
+        <p:spPr>
+          <a:xfrm>
+            <a:off x="9144000" y="5907024"/>
+            <a:ext cx="2651760" cy="521208"/>
           </a:xfrm>
           <a:prstGeom prst="rect">
             <a:avLst/>
@@ -7731,47 +7940,13 @@
           <a:p>
             <a:pPr algn="l"/>
             <a:r>
-              <a:rPr sz="1300" b="1" i="0">
-                <a:solidFill>
-                  <a:srgbClr val="378644"/>
-                </a:solidFill>
-              </a:rPr>
-              <a:t>NOAEL</a:t>
-            </a:r>
-          </a:p>
-        </p:txBody>
-      </p:sp>
-      <p:sp>
-        <p:nvSpPr>
-          <p:cNvPr id="17" name="TextBox 16"/>
-          <p:cNvSpPr txBox="1"/>
-          <p:nvPr/>
-        </p:nvSpPr>
-        <p:spPr>
-          <a:xfrm>
-            <a:off x="9144000" y="5852160"/>
-            <a:ext cx="2651760" cy="502920"/>
-          </a:xfrm>
-          <a:prstGeom prst="rect">
-            <a:avLst/>
-          </a:prstGeom>
-          <a:noFill/>
-        </p:spPr>
-        <p:txBody>
-          <a:bodyPr wrap="square">
-            <a:spAutoFit/>
-          </a:bodyPr>
-          <a:lstStyle/>
-          <a:p>
-            <a:pPr algn="l"/>
-            <a:r>
-              <a:rPr sz="1200" b="0" i="0">
-                <a:solidFill>
-                  <a:srgbClr val="378644"/>
-                </a:solidFill>
-              </a:rPr>
-              <a:t>Aucun grade ≥3 prédit
-à 4 mg/kg</a:t>
+              <a:rPr sz="1000" b="0" i="0">
+                <a:solidFill>
+                  <a:srgbClr val="1A1A1A"/>
+                </a:solidFill>
+              </a:rPr>
+              <a:t>→ Justifie l'approche
+PK/PD mécaniste</a:t>
             </a:r>
           </a:p>
         </p:txBody>
@@ -7866,7 +8041,7 @@
                   <a:srgbClr val="FFFFFF"/>
                 </a:solidFill>
               </a:rPr>
-              <a:t>Prochaines étapes</a:t>
+              <a:t>Projections PD — Simulation Q3W × 3 cycles + récupération</a:t>
             </a:r>
           </a:p>
         </p:txBody>
@@ -7900,7 +8075,7 @@
                   <a:srgbClr val="D6E4F0"/>
                 </a:solidFill>
               </a:rPr>
-              <a:t>De la caractérisation NHP à la prédiction clinique (FIH)</a:t>
+              <a:t>Profils prédits D0–D90 | % de la baseline individuelle | Sans données observées</a:t>
             </a:r>
           </a:p>
         </p:txBody>
@@ -7990,18 +8165,18 @@
         </p:nvSpPr>
         <p:spPr>
           <a:xfrm>
-            <a:off x="274320" y="1234440"/>
-            <a:ext cx="5669280" cy="2423160"/>
+            <a:off x="274320" y="1097280"/>
+            <a:ext cx="8686800" cy="5486400"/>
           </a:xfrm>
           <a:prstGeom prst="rect">
             <a:avLst/>
           </a:prstGeom>
           <a:solidFill>
-            <a:srgbClr val="FFFFFF"/>
+            <a:srgbClr val="F5F5F5"/>
           </a:solidFill>
-          <a:ln w="31750">
+          <a:ln w="12700">
             <a:solidFill>
-              <a:srgbClr val="2E75B6"/>
+              <a:srgbClr val="CCCCCC"/>
             </a:solidFill>
           </a:ln>
         </p:spPr>
@@ -8029,23 +8204,59 @@
       </p:sp>
       <p:sp>
         <p:nvSpPr>
-          <p:cNvPr id="8" name="Rectangle 7"/>
+          <p:cNvPr id="8" name="TextBox 7"/>
+          <p:cNvSpPr txBox="1"/>
+          <p:nvPr/>
+        </p:nvSpPr>
+        <p:spPr>
+          <a:xfrm>
+            <a:off x="365760" y="3657600"/>
+            <a:ext cx="8503920" cy="365760"/>
+          </a:xfrm>
+          <a:prstGeom prst="rect">
+            <a:avLst/>
+          </a:prstGeom>
+          <a:noFill/>
+        </p:spPr>
+        <p:txBody>
+          <a:bodyPr wrap="square">
+            <a:spAutoFit/>
+          </a:bodyPr>
+          <a:lstStyle/>
+          <a:p>
+            <a:pPr algn="ctr"/>
+            <a:r>
+              <a:rPr sz="1000" b="0" i="1">
+                <a:solidFill>
+                  <a:srgbClr val="CCCCCC"/>
+                </a:solidFill>
+              </a:rPr>
+              <a:t>[Image : poster_PD_predicted_individual_noobs.png]</a:t>
+            </a:r>
+          </a:p>
+        </p:txBody>
+      </p:sp>
+      <p:sp>
+        <p:nvSpPr>
+          <p:cNvPr id="9" name="Rectangle 8"/>
           <p:cNvSpPr/>
           <p:nvPr/>
         </p:nvSpPr>
         <p:spPr>
           <a:xfrm>
-            <a:off x="274320" y="1234440"/>
-            <a:ext cx="5669280" cy="411480"/>
+            <a:off x="9052560" y="1097280"/>
+            <a:ext cx="2834640" cy="5486400"/>
           </a:xfrm>
           <a:prstGeom prst="rect">
             <a:avLst/>
           </a:prstGeom>
           <a:solidFill>
-            <a:srgbClr val="2E75B6"/>
+            <a:srgbClr val="F5F5F5"/>
           </a:solidFill>
-          <a:ln w="19050">
-            <a:noFill/>
+          <a:ln w="6350">
+            <a:solidFill>
+              <a:srgbClr val="CCCCCC"/>
+            </a:solidFill>
           </a:ln>
         </p:spPr>
         <p:style>
@@ -8072,14 +8283,14 @@
       </p:sp>
       <p:sp>
         <p:nvSpPr>
-          <p:cNvPr id="9" name="TextBox 8"/>
-          <p:cNvSpPr txBox="1"/>
-          <p:nvPr/>
-        </p:nvSpPr>
-        <p:spPr>
-          <a:xfrm>
-            <a:off x="365760" y="1271016"/>
-            <a:ext cx="5486400" cy="347472"/>
+          <p:cNvPr id="10" name="TextBox 9"/>
+          <p:cNvSpPr txBox="1"/>
+          <p:nvPr/>
+        </p:nvSpPr>
+        <p:spPr>
+          <a:xfrm>
+            <a:off x="9144000" y="1188720"/>
+            <a:ext cx="2651760" cy="365760"/>
           </a:xfrm>
           <a:prstGeom prst="rect">
             <a:avLst/>
@@ -8094,26 +8305,235 @@
           <a:p>
             <a:pPr algn="l"/>
             <a:r>
+              <a:rPr sz="1500" b="1" i="0">
+                <a:solidFill>
+                  <a:srgbClr val="1A3A5C"/>
+                </a:solidFill>
+              </a:rPr>
+              <a:t>Points clés</a:t>
+            </a:r>
+          </a:p>
+        </p:txBody>
+      </p:sp>
+      <p:sp>
+        <p:nvSpPr>
+          <p:cNvPr id="11" name="TextBox 10"/>
+          <p:cNvSpPr txBox="1"/>
+          <p:nvPr/>
+        </p:nvSpPr>
+        <p:spPr>
+          <a:xfrm>
+            <a:off x="9144000" y="1645920"/>
+            <a:ext cx="2651760" cy="868680"/>
+          </a:xfrm>
+          <a:prstGeom prst="rect">
+            <a:avLst/>
+          </a:prstGeom>
+          <a:noFill/>
+        </p:spPr>
+        <p:txBody>
+          <a:bodyPr wrap="square">
+            <a:spAutoFit/>
+          </a:bodyPr>
+          <a:lstStyle/>
+          <a:p>
+            <a:pPr algn="l"/>
+            <a:r>
+              <a:rPr sz="1200" b="0" i="0">
+                <a:solidFill>
+                  <a:srgbClr val="1A1A1A"/>
+                </a:solidFill>
+              </a:rPr>
+              <a:t>▸ Effet cumulatif sur
+3 cycles visible</a:t>
+            </a:r>
+          </a:p>
+        </p:txBody>
+      </p:sp>
+      <p:sp>
+        <p:nvSpPr>
+          <p:cNvPr id="12" name="TextBox 11"/>
+          <p:cNvSpPr txBox="1"/>
+          <p:nvPr/>
+        </p:nvSpPr>
+        <p:spPr>
+          <a:xfrm>
+            <a:off x="9144000" y="2468880"/>
+            <a:ext cx="2651760" cy="868680"/>
+          </a:xfrm>
+          <a:prstGeom prst="rect">
+            <a:avLst/>
+          </a:prstGeom>
+          <a:noFill/>
+        </p:spPr>
+        <p:txBody>
+          <a:bodyPr wrap="square">
+            <a:spAutoFit/>
+          </a:bodyPr>
+          <a:lstStyle/>
+          <a:p>
+            <a:pPr algn="l"/>
+            <a:r>
+              <a:rPr sz="1200" b="0" i="0">
+                <a:solidFill>
+                  <a:srgbClr val="1A1A1A"/>
+                </a:solidFill>
+              </a:rPr>
+              <a:t>▸ Nadir le plus profond
+après la 3ᵉ dose (J42)</a:t>
+            </a:r>
+          </a:p>
+        </p:txBody>
+      </p:sp>
+      <p:sp>
+        <p:nvSpPr>
+          <p:cNvPr id="13" name="TextBox 12"/>
+          <p:cNvSpPr txBox="1"/>
+          <p:nvPr/>
+        </p:nvSpPr>
+        <p:spPr>
+          <a:xfrm>
+            <a:off x="9144000" y="3291840"/>
+            <a:ext cx="2651760" cy="868680"/>
+          </a:xfrm>
+          <a:prstGeom prst="rect">
+            <a:avLst/>
+          </a:prstGeom>
+          <a:noFill/>
+        </p:spPr>
+        <p:txBody>
+          <a:bodyPr wrap="square">
+            <a:spAutoFit/>
+          </a:bodyPr>
+          <a:lstStyle/>
+          <a:p>
+            <a:pPr algn="l"/>
+            <a:r>
+              <a:rPr sz="1200" b="0" i="0">
+                <a:solidFill>
+                  <a:srgbClr val="1A1A1A"/>
+                </a:solidFill>
+              </a:rPr>
+              <a:t>▸ Récupération partielle
+entre cycles</a:t>
+            </a:r>
+          </a:p>
+        </p:txBody>
+      </p:sp>
+      <p:sp>
+        <p:nvSpPr>
+          <p:cNvPr id="14" name="TextBox 13"/>
+          <p:cNvSpPr txBox="1"/>
+          <p:nvPr/>
+        </p:nvSpPr>
+        <p:spPr>
+          <a:xfrm>
+            <a:off x="9144000" y="4114800"/>
+            <a:ext cx="2651760" cy="868680"/>
+          </a:xfrm>
+          <a:prstGeom prst="rect">
+            <a:avLst/>
+          </a:prstGeom>
+          <a:noFill/>
+        </p:spPr>
+        <p:txBody>
+          <a:bodyPr wrap="square">
+            <a:spAutoFit/>
+          </a:bodyPr>
+          <a:lstStyle/>
+          <a:p>
+            <a:pPr algn="l"/>
+            <a:r>
+              <a:rPr sz="1200" b="0" i="0">
+                <a:solidFill>
+                  <a:srgbClr val="1A1A1A"/>
+                </a:solidFill>
+              </a:rPr>
+              <a:t>▸ Dose-réponse claire :
+39 mg/kg &gt; 26 &gt; 13 &gt; 4</a:t>
+            </a:r>
+          </a:p>
+        </p:txBody>
+      </p:sp>
+      <p:sp>
+        <p:nvSpPr>
+          <p:cNvPr id="15" name="TextBox 14"/>
+          <p:cNvSpPr txBox="1"/>
+          <p:nvPr/>
+        </p:nvSpPr>
+        <p:spPr>
+          <a:xfrm>
+            <a:off x="9144000" y="4937760"/>
+            <a:ext cx="2651760" cy="868680"/>
+          </a:xfrm>
+          <a:prstGeom prst="rect">
+            <a:avLst/>
+          </a:prstGeom>
+          <a:noFill/>
+        </p:spPr>
+        <p:txBody>
+          <a:bodyPr wrap="square">
+            <a:spAutoFit/>
+          </a:bodyPr>
+          <a:lstStyle/>
+          <a:p>
+            <a:pPr algn="l"/>
+            <a:r>
+              <a:rPr sz="1200" b="0" i="0">
+                <a:solidFill>
+                  <a:srgbClr val="1A1A1A"/>
+                </a:solidFill>
+              </a:rPr>
+              <a:t>▸ Retour à la baseline
+attendu ~J80–D90</a:t>
+            </a:r>
+          </a:p>
+        </p:txBody>
+      </p:sp>
+      <p:sp>
+        <p:nvSpPr>
+          <p:cNvPr id="16" name="TextBox 15"/>
+          <p:cNvSpPr txBox="1"/>
+          <p:nvPr/>
+        </p:nvSpPr>
+        <p:spPr>
+          <a:xfrm>
+            <a:off x="9144000" y="5577840"/>
+            <a:ext cx="2651760" cy="274320"/>
+          </a:xfrm>
+          <a:prstGeom prst="rect">
+            <a:avLst/>
+          </a:prstGeom>
+          <a:noFill/>
+        </p:spPr>
+        <p:txBody>
+          <a:bodyPr wrap="square">
+            <a:spAutoFit/>
+          </a:bodyPr>
+          <a:lstStyle/>
+          <a:p>
+            <a:pPr algn="l"/>
+            <a:r>
               <a:rPr sz="1300" b="1" i="0">
                 <a:solidFill>
-                  <a:srgbClr val="FFFFFF"/>
-                </a:solidFill>
-              </a:rPr>
-              <a:t>1. Estimation formelle des paramètres PD</a:t>
-            </a:r>
-          </a:p>
-        </p:txBody>
-      </p:sp>
-      <p:sp>
-        <p:nvSpPr>
-          <p:cNvPr id="10" name="TextBox 9"/>
-          <p:cNvSpPr txBox="1"/>
-          <p:nvPr/>
-        </p:nvSpPr>
-        <p:spPr>
-          <a:xfrm>
-            <a:off x="411479" y="1709928"/>
-            <a:ext cx="5394960" cy="530352"/>
+                  <a:srgbClr val="378644"/>
+                </a:solidFill>
+              </a:rPr>
+              <a:t>NOAEL</a:t>
+            </a:r>
+          </a:p>
+        </p:txBody>
+      </p:sp>
+      <p:sp>
+        <p:nvSpPr>
+          <p:cNvPr id="17" name="TextBox 16"/>
+          <p:cNvSpPr txBox="1"/>
+          <p:nvPr/>
+        </p:nvSpPr>
+        <p:spPr>
+          <a:xfrm>
+            <a:off x="9144000" y="5852160"/>
+            <a:ext cx="2651760" cy="502920"/>
           </a:xfrm>
           <a:prstGeom prst="rect">
             <a:avLst/>
@@ -8128,752 +8548,13 @@
           <a:p>
             <a:pPr algn="l"/>
             <a:r>
-              <a:rPr sz="1150" b="0" i="0">
-                <a:solidFill>
-                  <a:srgbClr val="1A1A1A"/>
-                </a:solidFill>
-              </a:rPr>
-              <a:t>▸ Remplacer l'ajustement visuel par une optimisation numérique (Nelder-Mead ou NLME)</a:t>
-            </a:r>
-          </a:p>
-        </p:txBody>
-      </p:sp>
-      <p:sp>
-        <p:nvSpPr>
-          <p:cNvPr id="11" name="TextBox 10"/>
-          <p:cNvSpPr txBox="1"/>
-          <p:nvPr/>
-        </p:nvSpPr>
-        <p:spPr>
-          <a:xfrm>
-            <a:off x="411479" y="2276856"/>
-            <a:ext cx="5394960" cy="530352"/>
-          </a:xfrm>
-          <a:prstGeom prst="rect">
-            <a:avLst/>
-          </a:prstGeom>
-          <a:noFill/>
-        </p:spPr>
-        <p:txBody>
-          <a:bodyPr wrap="square">
-            <a:spAutoFit/>
-          </a:bodyPr>
-          <a:lstStyle/>
-          <a:p>
-            <a:pPr algn="l"/>
-            <a:r>
-              <a:rPr sz="1150" b="0" i="0">
-                <a:solidFill>
-                  <a:srgbClr val="1A1A1A"/>
-                </a:solidFill>
-              </a:rPr>
-              <a:t>▸ Quantifier l'incertitude sur Slope_MPP, Slope_CMP, Slope_MEP</a:t>
-            </a:r>
-          </a:p>
-        </p:txBody>
-      </p:sp>
-      <p:sp>
-        <p:nvSpPr>
-          <p:cNvPr id="12" name="TextBox 11"/>
-          <p:cNvSpPr txBox="1"/>
-          <p:nvPr/>
-        </p:nvSpPr>
-        <p:spPr>
-          <a:xfrm>
-            <a:off x="411479" y="2843784"/>
-            <a:ext cx="5394960" cy="530352"/>
-          </a:xfrm>
-          <a:prstGeom prst="rect">
-            <a:avLst/>
-          </a:prstGeom>
-          <a:noFill/>
-        </p:spPr>
-        <p:txBody>
-          <a:bodyPr wrap="square">
-            <a:spAutoFit/>
-          </a:bodyPr>
-          <a:lstStyle/>
-          <a:p>
-            <a:pPr algn="l"/>
-            <a:r>
-              <a:rPr sz="1150" b="0" i="0">
-                <a:solidFill>
-                  <a:srgbClr val="1A1A1A"/>
-                </a:solidFill>
-              </a:rPr>
-              <a:t>▸ Calculer des intervalles de confiance sur les nadirs prédits</a:t>
-            </a:r>
-          </a:p>
-        </p:txBody>
-      </p:sp>
-      <p:sp>
-        <p:nvSpPr>
-          <p:cNvPr id="13" name="Rectangle 12"/>
-          <p:cNvSpPr/>
-          <p:nvPr/>
-        </p:nvSpPr>
-        <p:spPr>
-          <a:xfrm>
-            <a:off x="6217920" y="1234440"/>
-            <a:ext cx="5669280" cy="2423160"/>
-          </a:xfrm>
-          <a:prstGeom prst="rect">
-            <a:avLst/>
-          </a:prstGeom>
-          <a:solidFill>
-            <a:srgbClr val="FFFFFF"/>
-          </a:solidFill>
-          <a:ln w="31750">
-            <a:solidFill>
-              <a:srgbClr val="378644"/>
-            </a:solidFill>
-          </a:ln>
-        </p:spPr>
-        <p:style>
-          <a:lnRef idx="1">
-            <a:schemeClr val="accent1"/>
-          </a:lnRef>
-          <a:fillRef idx="3">
-            <a:schemeClr val="accent1"/>
-          </a:fillRef>
-          <a:effectRef idx="2">
-            <a:schemeClr val="accent1"/>
-          </a:effectRef>
-          <a:fontRef idx="minor">
-            <a:schemeClr val="lt1"/>
-          </a:fontRef>
-        </p:style>
-        <p:txBody>
-          <a:bodyPr rtlCol="0" anchor="ctr"/>
-          <a:lstStyle/>
-          <a:p>
-            <a:pPr algn="ctr"/>
-          </a:p>
-        </p:txBody>
-      </p:sp>
-      <p:sp>
-        <p:nvSpPr>
-          <p:cNvPr id="14" name="Rectangle 13"/>
-          <p:cNvSpPr/>
-          <p:nvPr/>
-        </p:nvSpPr>
-        <p:spPr>
-          <a:xfrm>
-            <a:off x="6217920" y="1234440"/>
-            <a:ext cx="5669280" cy="411480"/>
-          </a:xfrm>
-          <a:prstGeom prst="rect">
-            <a:avLst/>
-          </a:prstGeom>
-          <a:solidFill>
-            <a:srgbClr val="378644"/>
-          </a:solidFill>
-          <a:ln w="19050">
-            <a:noFill/>
-          </a:ln>
-        </p:spPr>
-        <p:style>
-          <a:lnRef idx="1">
-            <a:schemeClr val="accent1"/>
-          </a:lnRef>
-          <a:fillRef idx="3">
-            <a:schemeClr val="accent1"/>
-          </a:fillRef>
-          <a:effectRef idx="2">
-            <a:schemeClr val="accent1"/>
-          </a:effectRef>
-          <a:fontRef idx="minor">
-            <a:schemeClr val="lt1"/>
-          </a:fontRef>
-        </p:style>
-        <p:txBody>
-          <a:bodyPr rtlCol="0" anchor="ctr"/>
-          <a:lstStyle/>
-          <a:p>
-            <a:pPr algn="ctr"/>
-          </a:p>
-        </p:txBody>
-      </p:sp>
-      <p:sp>
-        <p:nvSpPr>
-          <p:cNvPr id="15" name="TextBox 14"/>
-          <p:cNvSpPr txBox="1"/>
-          <p:nvPr/>
-        </p:nvSpPr>
-        <p:spPr>
-          <a:xfrm>
-            <a:off x="6309359" y="1271016"/>
-            <a:ext cx="5486400" cy="347472"/>
-          </a:xfrm>
-          <a:prstGeom prst="rect">
-            <a:avLst/>
-          </a:prstGeom>
-          <a:noFill/>
-        </p:spPr>
-        <p:txBody>
-          <a:bodyPr wrap="square">
-            <a:spAutoFit/>
-          </a:bodyPr>
-          <a:lstStyle/>
-          <a:p>
-            <a:pPr algn="l"/>
-            <a:r>
-              <a:rPr sz="1300" b="1" i="0">
-                <a:solidFill>
-                  <a:srgbClr val="FFFFFF"/>
-                </a:solidFill>
-              </a:rPr>
-              <a:t>2. Transposition PK NHP → Humain</a:t>
-            </a:r>
-          </a:p>
-        </p:txBody>
-      </p:sp>
-      <p:sp>
-        <p:nvSpPr>
-          <p:cNvPr id="16" name="TextBox 15"/>
-          <p:cNvSpPr txBox="1"/>
-          <p:nvPr/>
-        </p:nvSpPr>
-        <p:spPr>
-          <a:xfrm>
-            <a:off x="6355080" y="1709928"/>
-            <a:ext cx="5394960" cy="530352"/>
-          </a:xfrm>
-          <a:prstGeom prst="rect">
-            <a:avLst/>
-          </a:prstGeom>
-          <a:noFill/>
-        </p:spPr>
-        <p:txBody>
-          <a:bodyPr wrap="square">
-            <a:spAutoFit/>
-          </a:bodyPr>
-          <a:lstStyle/>
-          <a:p>
-            <a:pPr algn="l"/>
-            <a:r>
-              <a:rPr sz="1150" b="0" i="0">
-                <a:solidFill>
-                  <a:srgbClr val="1A1A1A"/>
-                </a:solidFill>
-              </a:rPr>
-              <a:t>▸ Allométrie standard : CL_hum = CL_NHP × (70/BW_NHP)⁰·⁷⁵</a:t>
-            </a:r>
-          </a:p>
-        </p:txBody>
-      </p:sp>
-      <p:sp>
-        <p:nvSpPr>
-          <p:cNvPr id="17" name="TextBox 16"/>
-          <p:cNvSpPr txBox="1"/>
-          <p:nvPr/>
-        </p:nvSpPr>
-        <p:spPr>
-          <a:xfrm>
-            <a:off x="6355080" y="2276856"/>
-            <a:ext cx="5394960" cy="530352"/>
-          </a:xfrm>
-          <a:prstGeom prst="rect">
-            <a:avLst/>
-          </a:prstGeom>
-          <a:noFill/>
-        </p:spPr>
-        <p:txBody>
-          <a:bodyPr wrap="square">
-            <a:spAutoFit/>
-          </a:bodyPr>
-          <a:lstStyle/>
-          <a:p>
-            <a:pPr algn="l"/>
-            <a:r>
-              <a:rPr sz="1150" b="0" i="0">
-                <a:solidFill>
-                  <a:srgbClr val="1A1A1A"/>
-                </a:solidFill>
-              </a:rPr>
-              <a:t>▸ Validée sur T-DXd (facteur erreur &lt; 2 sur CL)</a:t>
-            </a:r>
-          </a:p>
-        </p:txBody>
-      </p:sp>
-      <p:sp>
-        <p:nvSpPr>
-          <p:cNvPr id="18" name="TextBox 17"/>
-          <p:cNvSpPr txBox="1"/>
-          <p:nvPr/>
-        </p:nvSpPr>
-        <p:spPr>
-          <a:xfrm>
-            <a:off x="6355080" y="2843784"/>
-            <a:ext cx="5394960" cy="530352"/>
-          </a:xfrm>
-          <a:prstGeom prst="rect">
-            <a:avLst/>
-          </a:prstGeom>
-          <a:noFill/>
-        </p:spPr>
-        <p:txBody>
-          <a:bodyPr wrap="square">
-            <a:spAutoFit/>
-          </a:bodyPr>
-          <a:lstStyle/>
-          <a:p>
-            <a:pPr algn="l"/>
-            <a:r>
-              <a:rPr sz="1150" b="0" i="0">
-                <a:solidFill>
-                  <a:srgbClr val="1A1A1A"/>
-                </a:solidFill>
-              </a:rPr>
-              <a:t>▸ Générer les paramètres PK humains de départ</a:t>
-            </a:r>
-          </a:p>
-        </p:txBody>
-      </p:sp>
-      <p:sp>
-        <p:nvSpPr>
-          <p:cNvPr id="19" name="Rectangle 18"/>
-          <p:cNvSpPr/>
-          <p:nvPr/>
-        </p:nvSpPr>
-        <p:spPr>
-          <a:xfrm>
-            <a:off x="274320" y="3840480"/>
-            <a:ext cx="5669280" cy="2423160"/>
-          </a:xfrm>
-          <a:prstGeom prst="rect">
-            <a:avLst/>
-          </a:prstGeom>
-          <a:solidFill>
-            <a:srgbClr val="FFFFFF"/>
-          </a:solidFill>
-          <a:ln w="31750">
-            <a:solidFill>
-              <a:srgbClr val="C5501A"/>
-            </a:solidFill>
-          </a:ln>
-        </p:spPr>
-        <p:style>
-          <a:lnRef idx="1">
-            <a:schemeClr val="accent1"/>
-          </a:lnRef>
-          <a:fillRef idx="3">
-            <a:schemeClr val="accent1"/>
-          </a:fillRef>
-          <a:effectRef idx="2">
-            <a:schemeClr val="accent1"/>
-          </a:effectRef>
-          <a:fontRef idx="minor">
-            <a:schemeClr val="lt1"/>
-          </a:fontRef>
-        </p:style>
-        <p:txBody>
-          <a:bodyPr rtlCol="0" anchor="ctr"/>
-          <a:lstStyle/>
-          <a:p>
-            <a:pPr algn="ctr"/>
-          </a:p>
-        </p:txBody>
-      </p:sp>
-      <p:sp>
-        <p:nvSpPr>
-          <p:cNvPr id="20" name="Rectangle 19"/>
-          <p:cNvSpPr/>
-          <p:nvPr/>
-        </p:nvSpPr>
-        <p:spPr>
-          <a:xfrm>
-            <a:off x="274320" y="3840480"/>
-            <a:ext cx="5669280" cy="411480"/>
-          </a:xfrm>
-          <a:prstGeom prst="rect">
-            <a:avLst/>
-          </a:prstGeom>
-          <a:solidFill>
-            <a:srgbClr val="C5501A"/>
-          </a:solidFill>
-          <a:ln w="19050">
-            <a:noFill/>
-          </a:ln>
-        </p:spPr>
-        <p:style>
-          <a:lnRef idx="1">
-            <a:schemeClr val="accent1"/>
-          </a:lnRef>
-          <a:fillRef idx="3">
-            <a:schemeClr val="accent1"/>
-          </a:fillRef>
-          <a:effectRef idx="2">
-            <a:schemeClr val="accent1"/>
-          </a:effectRef>
-          <a:fontRef idx="minor">
-            <a:schemeClr val="lt1"/>
-          </a:fontRef>
-        </p:style>
-        <p:txBody>
-          <a:bodyPr rtlCol="0" anchor="ctr"/>
-          <a:lstStyle/>
-          <a:p>
-            <a:pPr algn="ctr"/>
-          </a:p>
-        </p:txBody>
-      </p:sp>
-      <p:sp>
-        <p:nvSpPr>
-          <p:cNvPr id="21" name="TextBox 20"/>
-          <p:cNvSpPr txBox="1"/>
-          <p:nvPr/>
-        </p:nvSpPr>
-        <p:spPr>
-          <a:xfrm>
-            <a:off x="365760" y="3877056"/>
-            <a:ext cx="5486400" cy="347472"/>
-          </a:xfrm>
-          <a:prstGeom prst="rect">
-            <a:avLst/>
-          </a:prstGeom>
-          <a:noFill/>
-        </p:spPr>
-        <p:txBody>
-          <a:bodyPr wrap="square">
-            <a:spAutoFit/>
-          </a:bodyPr>
-          <a:lstStyle/>
-          <a:p>
-            <a:pPr algn="l"/>
-            <a:r>
-              <a:rPr sz="1300" b="1" i="0">
-                <a:solidFill>
-                  <a:srgbClr val="FFFFFF"/>
-                </a:solidFill>
-              </a:rPr>
-              <a:t>3. Simulation de la toxicité humaine attendue</a:t>
-            </a:r>
-          </a:p>
-        </p:txBody>
-      </p:sp>
-      <p:sp>
-        <p:nvSpPr>
-          <p:cNvPr id="22" name="TextBox 21"/>
-          <p:cNvSpPr txBox="1"/>
-          <p:nvPr/>
-        </p:nvSpPr>
-        <p:spPr>
-          <a:xfrm>
-            <a:off x="411479" y="4315968"/>
-            <a:ext cx="5394960" cy="530352"/>
-          </a:xfrm>
-          <a:prstGeom prst="rect">
-            <a:avLst/>
-          </a:prstGeom>
-          <a:noFill/>
-        </p:spPr>
-        <p:txBody>
-          <a:bodyPr wrap="square">
-            <a:spAutoFit/>
-          </a:bodyPr>
-          <a:lstStyle/>
-          <a:p>
-            <a:pPr algn="l"/>
-            <a:r>
-              <a:rPr sz="1150" b="0" i="0">
-                <a:solidFill>
-                  <a:srgbClr val="1A1A1A"/>
-                </a:solidFill>
-              </a:rPr>
-              <a:t>▸ Utiliser les Slopes NHP comme estimation initiale chez l'humain</a:t>
-            </a:r>
-          </a:p>
-        </p:txBody>
-      </p:sp>
-      <p:sp>
-        <p:nvSpPr>
-          <p:cNvPr id="23" name="TextBox 22"/>
-          <p:cNvSpPr txBox="1"/>
-          <p:nvPr/>
-        </p:nvSpPr>
-        <p:spPr>
-          <a:xfrm>
-            <a:off x="411479" y="4882896"/>
-            <a:ext cx="5394960" cy="530352"/>
-          </a:xfrm>
-          <a:prstGeom prst="rect">
-            <a:avLst/>
-          </a:prstGeom>
-          <a:noFill/>
-        </p:spPr>
-        <p:txBody>
-          <a:bodyPr wrap="square">
-            <a:spAutoFit/>
-          </a:bodyPr>
-          <a:lstStyle/>
-          <a:p>
-            <a:pPr algn="l"/>
-            <a:r>
-              <a:rPr sz="1150" b="0" i="0">
-                <a:solidFill>
-                  <a:srgbClr val="1A1A1A"/>
-                </a:solidFill>
-              </a:rPr>
-              <a:t>▸ Simuler N=300 patients virtuels (IIV log-normal)</a:t>
-            </a:r>
-          </a:p>
-        </p:txBody>
-      </p:sp>
-      <p:sp>
-        <p:nvSpPr>
-          <p:cNvPr id="24" name="TextBox 23"/>
-          <p:cNvSpPr txBox="1"/>
-          <p:nvPr/>
-        </p:nvSpPr>
-        <p:spPr>
-          <a:xfrm>
-            <a:off x="411479" y="5449824"/>
-            <a:ext cx="5394960" cy="530352"/>
-          </a:xfrm>
-          <a:prstGeom prst="rect">
-            <a:avLst/>
-          </a:prstGeom>
-          <a:noFill/>
-        </p:spPr>
-        <p:txBody>
-          <a:bodyPr wrap="square">
-            <a:spAutoFit/>
-          </a:bodyPr>
-          <a:lstStyle/>
-          <a:p>
-            <a:pPr algn="l"/>
-            <a:r>
-              <a:rPr sz="1150" b="0" i="0">
-                <a:solidFill>
-                  <a:srgbClr val="1A1A1A"/>
-                </a:solidFill>
-              </a:rPr>
-              <a:t>▸ Prédire la distribution des grades CTCAE v5 à différentes doses FIH</a:t>
-            </a:r>
-          </a:p>
-        </p:txBody>
-      </p:sp>
-      <p:sp>
-        <p:nvSpPr>
-          <p:cNvPr id="25" name="Rectangle 24"/>
-          <p:cNvSpPr/>
-          <p:nvPr/>
-        </p:nvSpPr>
-        <p:spPr>
-          <a:xfrm>
-            <a:off x="6217920" y="3840480"/>
-            <a:ext cx="5669280" cy="2423160"/>
-          </a:xfrm>
-          <a:prstGeom prst="rect">
-            <a:avLst/>
-          </a:prstGeom>
-          <a:solidFill>
-            <a:srgbClr val="FFFFFF"/>
-          </a:solidFill>
-          <a:ln w="31750">
-            <a:solidFill>
-              <a:srgbClr val="60328A"/>
-            </a:solidFill>
-          </a:ln>
-        </p:spPr>
-        <p:style>
-          <a:lnRef idx="1">
-            <a:schemeClr val="accent1"/>
-          </a:lnRef>
-          <a:fillRef idx="3">
-            <a:schemeClr val="accent1"/>
-          </a:fillRef>
-          <a:effectRef idx="2">
-            <a:schemeClr val="accent1"/>
-          </a:effectRef>
-          <a:fontRef idx="minor">
-            <a:schemeClr val="lt1"/>
-          </a:fontRef>
-        </p:style>
-        <p:txBody>
-          <a:bodyPr rtlCol="0" anchor="ctr"/>
-          <a:lstStyle/>
-          <a:p>
-            <a:pPr algn="ctr"/>
-          </a:p>
-        </p:txBody>
-      </p:sp>
-      <p:sp>
-        <p:nvSpPr>
-          <p:cNvPr id="26" name="Rectangle 25"/>
-          <p:cNvSpPr/>
-          <p:nvPr/>
-        </p:nvSpPr>
-        <p:spPr>
-          <a:xfrm>
-            <a:off x="6217920" y="3840480"/>
-            <a:ext cx="5669280" cy="411480"/>
-          </a:xfrm>
-          <a:prstGeom prst="rect">
-            <a:avLst/>
-          </a:prstGeom>
-          <a:solidFill>
-            <a:srgbClr val="60328A"/>
-          </a:solidFill>
-          <a:ln w="19050">
-            <a:noFill/>
-          </a:ln>
-        </p:spPr>
-        <p:style>
-          <a:lnRef idx="1">
-            <a:schemeClr val="accent1"/>
-          </a:lnRef>
-          <a:fillRef idx="3">
-            <a:schemeClr val="accent1"/>
-          </a:fillRef>
-          <a:effectRef idx="2">
-            <a:schemeClr val="accent1"/>
-          </a:effectRef>
-          <a:fontRef idx="minor">
-            <a:schemeClr val="lt1"/>
-          </a:fontRef>
-        </p:style>
-        <p:txBody>
-          <a:bodyPr rtlCol="0" anchor="ctr"/>
-          <a:lstStyle/>
-          <a:p>
-            <a:pPr algn="ctr"/>
-          </a:p>
-        </p:txBody>
-      </p:sp>
-      <p:sp>
-        <p:nvSpPr>
-          <p:cNvPr id="27" name="TextBox 26"/>
-          <p:cNvSpPr txBox="1"/>
-          <p:nvPr/>
-        </p:nvSpPr>
-        <p:spPr>
-          <a:xfrm>
-            <a:off x="6309359" y="3877056"/>
-            <a:ext cx="5486400" cy="347472"/>
-          </a:xfrm>
-          <a:prstGeom prst="rect">
-            <a:avLst/>
-          </a:prstGeom>
-          <a:noFill/>
-        </p:spPr>
-        <p:txBody>
-          <a:bodyPr wrap="square">
-            <a:spAutoFit/>
-          </a:bodyPr>
-          <a:lstStyle/>
-          <a:p>
-            <a:pPr algn="l"/>
-            <a:r>
-              <a:rPr sz="1300" b="1" i="0">
-                <a:solidFill>
-                  <a:srgbClr val="FFFFFF"/>
-                </a:solidFill>
-              </a:rPr>
-              <a:t>4. Support à la dose de départ FIH</a:t>
-            </a:r>
-          </a:p>
-        </p:txBody>
-      </p:sp>
-      <p:sp>
-        <p:nvSpPr>
-          <p:cNvPr id="28" name="TextBox 27"/>
-          <p:cNvSpPr txBox="1"/>
-          <p:nvPr/>
-        </p:nvSpPr>
-        <p:spPr>
-          <a:xfrm>
-            <a:off x="6355080" y="4315968"/>
-            <a:ext cx="5394960" cy="530352"/>
-          </a:xfrm>
-          <a:prstGeom prst="rect">
-            <a:avLst/>
-          </a:prstGeom>
-          <a:noFill/>
-        </p:spPr>
-        <p:txBody>
-          <a:bodyPr wrap="square">
-            <a:spAutoFit/>
-          </a:bodyPr>
-          <a:lstStyle/>
-          <a:p>
-            <a:pPr algn="l"/>
-            <a:r>
-              <a:rPr sz="1150" b="0" i="0">
-                <a:solidFill>
-                  <a:srgbClr val="1A1A1A"/>
-                </a:solidFill>
-              </a:rPr>
-              <a:t>▸ Identifier la dose associée à P(G≥3) &lt; 10%</a:t>
-            </a:r>
-          </a:p>
-        </p:txBody>
-      </p:sp>
-      <p:sp>
-        <p:nvSpPr>
-          <p:cNvPr id="29" name="TextBox 28"/>
-          <p:cNvSpPr txBox="1"/>
-          <p:nvPr/>
-        </p:nvSpPr>
-        <p:spPr>
-          <a:xfrm>
-            <a:off x="6355080" y="4882896"/>
-            <a:ext cx="5394960" cy="530352"/>
-          </a:xfrm>
-          <a:prstGeom prst="rect">
-            <a:avLst/>
-          </a:prstGeom>
-          <a:noFill/>
-        </p:spPr>
-        <p:txBody>
-          <a:bodyPr wrap="square">
-            <a:spAutoFit/>
-          </a:bodyPr>
-          <a:lstStyle/>
-          <a:p>
-            <a:pPr algn="l"/>
-            <a:r>
-              <a:rPr sz="1150" b="0" i="0">
-                <a:solidFill>
-                  <a:srgbClr val="1A1A1A"/>
-                </a:solidFill>
-              </a:rPr>
-              <a:t>▸ Intégrer le NOAEL NHP comme contrainte de sécurité</a:t>
-            </a:r>
-          </a:p>
-        </p:txBody>
-      </p:sp>
-      <p:sp>
-        <p:nvSpPr>
-          <p:cNvPr id="30" name="TextBox 29"/>
-          <p:cNvSpPr txBox="1"/>
-          <p:nvPr/>
-        </p:nvSpPr>
-        <p:spPr>
-          <a:xfrm>
-            <a:off x="6355080" y="5449824"/>
-            <a:ext cx="5394960" cy="530352"/>
-          </a:xfrm>
-          <a:prstGeom prst="rect">
-            <a:avLst/>
-          </a:prstGeom>
-          <a:noFill/>
-        </p:spPr>
-        <p:txBody>
-          <a:bodyPr wrap="square">
-            <a:spAutoFit/>
-          </a:bodyPr>
-          <a:lstStyle/>
-          <a:p>
-            <a:pPr algn="l"/>
-            <a:r>
-              <a:rPr sz="1150" b="0" i="0">
-                <a:solidFill>
-                  <a:srgbClr val="1A1A1A"/>
-                </a:solidFill>
-              </a:rPr>
-              <a:t>▸ Documenter pour le dossier IND/CTA (FDA/EMA)</a:t>
+              <a:rPr sz="1200" b="0" i="0">
+                <a:solidFill>
+                  <a:srgbClr val="378644"/>
+                </a:solidFill>
+              </a:rPr>
+              <a:t>Aucun grade ≥3 prédit
+à 4 mg/kg</a:t>
             </a:r>
           </a:p>
         </p:txBody>
@@ -8887,6 +8568,1108 @@
 </file>
 
 <file path=ppt/slides/slide7.xml><?xml version="1.0" encoding="utf-8"?>
+<p:sld xmlns:a="http://schemas.openxmlformats.org/drawingml/2006/main" xmlns:p="http://schemas.openxmlformats.org/presentationml/2006/main" xmlns:r="http://schemas.openxmlformats.org/officeDocument/2006/relationships">
+  <p:cSld>
+    <p:spTree>
+      <p:nvGrpSpPr>
+        <p:cNvPr id="1" name=""/>
+        <p:cNvGrpSpPr/>
+        <p:nvPr/>
+      </p:nvGrpSpPr>
+      <p:grpSpPr/>
+      <p:sp>
+        <p:nvSpPr>
+          <p:cNvPr id="2" name="Rectangle 1"/>
+          <p:cNvSpPr/>
+          <p:nvPr/>
+        </p:nvSpPr>
+        <p:spPr>
+          <a:xfrm>
+            <a:off x="0" y="0"/>
+            <a:ext cx="12188952" cy="1051560"/>
+          </a:xfrm>
+          <a:prstGeom prst="rect">
+            <a:avLst/>
+          </a:prstGeom>
+          <a:solidFill>
+            <a:srgbClr val="1A3A5C"/>
+          </a:solidFill>
+          <a:ln w="19050">
+            <a:noFill/>
+          </a:ln>
+        </p:spPr>
+        <p:style>
+          <a:lnRef idx="1">
+            <a:schemeClr val="accent1"/>
+          </a:lnRef>
+          <a:fillRef idx="3">
+            <a:schemeClr val="accent1"/>
+          </a:fillRef>
+          <a:effectRef idx="2">
+            <a:schemeClr val="accent1"/>
+          </a:effectRef>
+          <a:fontRef idx="minor">
+            <a:schemeClr val="lt1"/>
+          </a:fontRef>
+        </p:style>
+        <p:txBody>
+          <a:bodyPr rtlCol="0" anchor="ctr"/>
+          <a:lstStyle/>
+          <a:p>
+            <a:pPr algn="ctr"/>
+          </a:p>
+        </p:txBody>
+      </p:sp>
+      <p:sp>
+        <p:nvSpPr>
+          <p:cNvPr id="3" name="TextBox 2"/>
+          <p:cNvSpPr txBox="1"/>
+          <p:nvPr/>
+        </p:nvSpPr>
+        <p:spPr>
+          <a:xfrm>
+            <a:off x="320040" y="73152"/>
+            <a:ext cx="11430000" cy="594360"/>
+          </a:xfrm>
+          <a:prstGeom prst="rect">
+            <a:avLst/>
+          </a:prstGeom>
+          <a:noFill/>
+        </p:spPr>
+        <p:txBody>
+          <a:bodyPr wrap="square">
+            <a:spAutoFit/>
+          </a:bodyPr>
+          <a:lstStyle/>
+          <a:p>
+            <a:pPr algn="l"/>
+            <a:r>
+              <a:rPr sz="2400" b="1" i="0">
+                <a:solidFill>
+                  <a:srgbClr val="FFFFFF"/>
+                </a:solidFill>
+              </a:rPr>
+              <a:t>Prochaines étapes</a:t>
+            </a:r>
+          </a:p>
+        </p:txBody>
+      </p:sp>
+      <p:sp>
+        <p:nvSpPr>
+          <p:cNvPr id="4" name="TextBox 3"/>
+          <p:cNvSpPr txBox="1"/>
+          <p:nvPr/>
+        </p:nvSpPr>
+        <p:spPr>
+          <a:xfrm>
+            <a:off x="320040" y="658368"/>
+            <a:ext cx="11430000" cy="347472"/>
+          </a:xfrm>
+          <a:prstGeom prst="rect">
+            <a:avLst/>
+          </a:prstGeom>
+          <a:noFill/>
+        </p:spPr>
+        <p:txBody>
+          <a:bodyPr wrap="square">
+            <a:spAutoFit/>
+          </a:bodyPr>
+          <a:lstStyle/>
+          <a:p>
+            <a:pPr algn="l"/>
+            <a:r>
+              <a:rPr sz="1400" b="0" i="1">
+                <a:solidFill>
+                  <a:srgbClr val="D6E4F0"/>
+                </a:solidFill>
+              </a:rPr>
+              <a:t>De la caractérisation NHP à la prédiction clinique (FIH)</a:t>
+            </a:r>
+          </a:p>
+        </p:txBody>
+      </p:sp>
+      <p:sp>
+        <p:nvSpPr>
+          <p:cNvPr id="5" name="Rectangle 4"/>
+          <p:cNvSpPr/>
+          <p:nvPr/>
+        </p:nvSpPr>
+        <p:spPr>
+          <a:xfrm>
+            <a:off x="0" y="6583680"/>
+            <a:ext cx="12188952" cy="274320"/>
+          </a:xfrm>
+          <a:prstGeom prst="rect">
+            <a:avLst/>
+          </a:prstGeom>
+          <a:solidFill>
+            <a:srgbClr val="1A3A5C"/>
+          </a:solidFill>
+          <a:ln w="19050">
+            <a:noFill/>
+          </a:ln>
+        </p:spPr>
+        <p:style>
+          <a:lnRef idx="1">
+            <a:schemeClr val="accent1"/>
+          </a:lnRef>
+          <a:fillRef idx="3">
+            <a:schemeClr val="accent1"/>
+          </a:fillRef>
+          <a:effectRef idx="2">
+            <a:schemeClr val="accent1"/>
+          </a:effectRef>
+          <a:fontRef idx="minor">
+            <a:schemeClr val="lt1"/>
+          </a:fontRef>
+        </p:style>
+        <p:txBody>
+          <a:bodyPr rtlCol="0" anchor="ctr"/>
+          <a:lstStyle/>
+          <a:p>
+            <a:pPr algn="ctr"/>
+          </a:p>
+        </p:txBody>
+      </p:sp>
+      <p:sp>
+        <p:nvSpPr>
+          <p:cNvPr id="6" name="TextBox 5"/>
+          <p:cNvSpPr txBox="1"/>
+          <p:nvPr/>
+        </p:nvSpPr>
+        <p:spPr>
+          <a:xfrm>
+            <a:off x="274320" y="6592824"/>
+            <a:ext cx="11430000" cy="256032"/>
+          </a:xfrm>
+          <a:prstGeom prst="rect">
+            <a:avLst/>
+          </a:prstGeom>
+          <a:noFill/>
+        </p:spPr>
+        <p:txBody>
+          <a:bodyPr wrap="square">
+            <a:spAutoFit/>
+          </a:bodyPr>
+          <a:lstStyle/>
+          <a:p>
+            <a:pPr algn="l"/>
+            <a:r>
+              <a:rPr sz="900" b="0" i="1">
+                <a:solidFill>
+                  <a:srgbClr val="F5F5F5"/>
+                </a:solidFill>
+              </a:rPr>
+              <a:t>Confidentiel — Usage interne</a:t>
+            </a:r>
+          </a:p>
+        </p:txBody>
+      </p:sp>
+      <p:sp>
+        <p:nvSpPr>
+          <p:cNvPr id="7" name="Rectangle 6"/>
+          <p:cNvSpPr/>
+          <p:nvPr/>
+        </p:nvSpPr>
+        <p:spPr>
+          <a:xfrm>
+            <a:off x="274320" y="1234440"/>
+            <a:ext cx="5669280" cy="2423160"/>
+          </a:xfrm>
+          <a:prstGeom prst="rect">
+            <a:avLst/>
+          </a:prstGeom>
+          <a:solidFill>
+            <a:srgbClr val="FFFFFF"/>
+          </a:solidFill>
+          <a:ln w="31750">
+            <a:solidFill>
+              <a:srgbClr val="2E75B6"/>
+            </a:solidFill>
+          </a:ln>
+        </p:spPr>
+        <p:style>
+          <a:lnRef idx="1">
+            <a:schemeClr val="accent1"/>
+          </a:lnRef>
+          <a:fillRef idx="3">
+            <a:schemeClr val="accent1"/>
+          </a:fillRef>
+          <a:effectRef idx="2">
+            <a:schemeClr val="accent1"/>
+          </a:effectRef>
+          <a:fontRef idx="minor">
+            <a:schemeClr val="lt1"/>
+          </a:fontRef>
+        </p:style>
+        <p:txBody>
+          <a:bodyPr rtlCol="0" anchor="ctr"/>
+          <a:lstStyle/>
+          <a:p>
+            <a:pPr algn="ctr"/>
+          </a:p>
+        </p:txBody>
+      </p:sp>
+      <p:sp>
+        <p:nvSpPr>
+          <p:cNvPr id="8" name="Rectangle 7"/>
+          <p:cNvSpPr/>
+          <p:nvPr/>
+        </p:nvSpPr>
+        <p:spPr>
+          <a:xfrm>
+            <a:off x="274320" y="1234440"/>
+            <a:ext cx="5669280" cy="411480"/>
+          </a:xfrm>
+          <a:prstGeom prst="rect">
+            <a:avLst/>
+          </a:prstGeom>
+          <a:solidFill>
+            <a:srgbClr val="2E75B6"/>
+          </a:solidFill>
+          <a:ln w="19050">
+            <a:noFill/>
+          </a:ln>
+        </p:spPr>
+        <p:style>
+          <a:lnRef idx="1">
+            <a:schemeClr val="accent1"/>
+          </a:lnRef>
+          <a:fillRef idx="3">
+            <a:schemeClr val="accent1"/>
+          </a:fillRef>
+          <a:effectRef idx="2">
+            <a:schemeClr val="accent1"/>
+          </a:effectRef>
+          <a:fontRef idx="minor">
+            <a:schemeClr val="lt1"/>
+          </a:fontRef>
+        </p:style>
+        <p:txBody>
+          <a:bodyPr rtlCol="0" anchor="ctr"/>
+          <a:lstStyle/>
+          <a:p>
+            <a:pPr algn="ctr"/>
+          </a:p>
+        </p:txBody>
+      </p:sp>
+      <p:sp>
+        <p:nvSpPr>
+          <p:cNvPr id="9" name="TextBox 8"/>
+          <p:cNvSpPr txBox="1"/>
+          <p:nvPr/>
+        </p:nvSpPr>
+        <p:spPr>
+          <a:xfrm>
+            <a:off x="365760" y="1271016"/>
+            <a:ext cx="5486400" cy="347472"/>
+          </a:xfrm>
+          <a:prstGeom prst="rect">
+            <a:avLst/>
+          </a:prstGeom>
+          <a:noFill/>
+        </p:spPr>
+        <p:txBody>
+          <a:bodyPr wrap="square">
+            <a:spAutoFit/>
+          </a:bodyPr>
+          <a:lstStyle/>
+          <a:p>
+            <a:pPr algn="l"/>
+            <a:r>
+              <a:rPr sz="1300" b="1" i="0">
+                <a:solidFill>
+                  <a:srgbClr val="FFFFFF"/>
+                </a:solidFill>
+              </a:rPr>
+              <a:t>1. Estimation formelle des paramètres PD</a:t>
+            </a:r>
+          </a:p>
+        </p:txBody>
+      </p:sp>
+      <p:sp>
+        <p:nvSpPr>
+          <p:cNvPr id="10" name="TextBox 9"/>
+          <p:cNvSpPr txBox="1"/>
+          <p:nvPr/>
+        </p:nvSpPr>
+        <p:spPr>
+          <a:xfrm>
+            <a:off x="411479" y="1709928"/>
+            <a:ext cx="5394960" cy="530352"/>
+          </a:xfrm>
+          <a:prstGeom prst="rect">
+            <a:avLst/>
+          </a:prstGeom>
+          <a:noFill/>
+        </p:spPr>
+        <p:txBody>
+          <a:bodyPr wrap="square">
+            <a:spAutoFit/>
+          </a:bodyPr>
+          <a:lstStyle/>
+          <a:p>
+            <a:pPr algn="l"/>
+            <a:r>
+              <a:rPr sz="1150" b="0" i="0">
+                <a:solidFill>
+                  <a:srgbClr val="1A1A1A"/>
+                </a:solidFill>
+              </a:rPr>
+              <a:t>▸ Remplacer l'ajustement visuel par une optimisation numérique (Nelder-Mead ou NLME)</a:t>
+            </a:r>
+          </a:p>
+        </p:txBody>
+      </p:sp>
+      <p:sp>
+        <p:nvSpPr>
+          <p:cNvPr id="11" name="TextBox 10"/>
+          <p:cNvSpPr txBox="1"/>
+          <p:nvPr/>
+        </p:nvSpPr>
+        <p:spPr>
+          <a:xfrm>
+            <a:off x="411479" y="2276856"/>
+            <a:ext cx="5394960" cy="530352"/>
+          </a:xfrm>
+          <a:prstGeom prst="rect">
+            <a:avLst/>
+          </a:prstGeom>
+          <a:noFill/>
+        </p:spPr>
+        <p:txBody>
+          <a:bodyPr wrap="square">
+            <a:spAutoFit/>
+          </a:bodyPr>
+          <a:lstStyle/>
+          <a:p>
+            <a:pPr algn="l"/>
+            <a:r>
+              <a:rPr sz="1150" b="0" i="0">
+                <a:solidFill>
+                  <a:srgbClr val="1A1A1A"/>
+                </a:solidFill>
+              </a:rPr>
+              <a:t>▸ Quantifier l'incertitude sur Slope_MPP, Slope_CMP, Slope_MEP</a:t>
+            </a:r>
+          </a:p>
+        </p:txBody>
+      </p:sp>
+      <p:sp>
+        <p:nvSpPr>
+          <p:cNvPr id="12" name="TextBox 11"/>
+          <p:cNvSpPr txBox="1"/>
+          <p:nvPr/>
+        </p:nvSpPr>
+        <p:spPr>
+          <a:xfrm>
+            <a:off x="411479" y="2843784"/>
+            <a:ext cx="5394960" cy="530352"/>
+          </a:xfrm>
+          <a:prstGeom prst="rect">
+            <a:avLst/>
+          </a:prstGeom>
+          <a:noFill/>
+        </p:spPr>
+        <p:txBody>
+          <a:bodyPr wrap="square">
+            <a:spAutoFit/>
+          </a:bodyPr>
+          <a:lstStyle/>
+          <a:p>
+            <a:pPr algn="l"/>
+            <a:r>
+              <a:rPr sz="1150" b="0" i="0">
+                <a:solidFill>
+                  <a:srgbClr val="1A1A1A"/>
+                </a:solidFill>
+              </a:rPr>
+              <a:t>▸ Calculer des intervalles de confiance sur les nadirs prédits</a:t>
+            </a:r>
+          </a:p>
+        </p:txBody>
+      </p:sp>
+      <p:sp>
+        <p:nvSpPr>
+          <p:cNvPr id="13" name="Rectangle 12"/>
+          <p:cNvSpPr/>
+          <p:nvPr/>
+        </p:nvSpPr>
+        <p:spPr>
+          <a:xfrm>
+            <a:off x="6217920" y="1234440"/>
+            <a:ext cx="5669280" cy="2423160"/>
+          </a:xfrm>
+          <a:prstGeom prst="rect">
+            <a:avLst/>
+          </a:prstGeom>
+          <a:solidFill>
+            <a:srgbClr val="FFFFFF"/>
+          </a:solidFill>
+          <a:ln w="31750">
+            <a:solidFill>
+              <a:srgbClr val="378644"/>
+            </a:solidFill>
+          </a:ln>
+        </p:spPr>
+        <p:style>
+          <a:lnRef idx="1">
+            <a:schemeClr val="accent1"/>
+          </a:lnRef>
+          <a:fillRef idx="3">
+            <a:schemeClr val="accent1"/>
+          </a:fillRef>
+          <a:effectRef idx="2">
+            <a:schemeClr val="accent1"/>
+          </a:effectRef>
+          <a:fontRef idx="minor">
+            <a:schemeClr val="lt1"/>
+          </a:fontRef>
+        </p:style>
+        <p:txBody>
+          <a:bodyPr rtlCol="0" anchor="ctr"/>
+          <a:lstStyle/>
+          <a:p>
+            <a:pPr algn="ctr"/>
+          </a:p>
+        </p:txBody>
+      </p:sp>
+      <p:sp>
+        <p:nvSpPr>
+          <p:cNvPr id="14" name="Rectangle 13"/>
+          <p:cNvSpPr/>
+          <p:nvPr/>
+        </p:nvSpPr>
+        <p:spPr>
+          <a:xfrm>
+            <a:off x="6217920" y="1234440"/>
+            <a:ext cx="5669280" cy="411480"/>
+          </a:xfrm>
+          <a:prstGeom prst="rect">
+            <a:avLst/>
+          </a:prstGeom>
+          <a:solidFill>
+            <a:srgbClr val="378644"/>
+          </a:solidFill>
+          <a:ln w="19050">
+            <a:noFill/>
+          </a:ln>
+        </p:spPr>
+        <p:style>
+          <a:lnRef idx="1">
+            <a:schemeClr val="accent1"/>
+          </a:lnRef>
+          <a:fillRef idx="3">
+            <a:schemeClr val="accent1"/>
+          </a:fillRef>
+          <a:effectRef idx="2">
+            <a:schemeClr val="accent1"/>
+          </a:effectRef>
+          <a:fontRef idx="minor">
+            <a:schemeClr val="lt1"/>
+          </a:fontRef>
+        </p:style>
+        <p:txBody>
+          <a:bodyPr rtlCol="0" anchor="ctr"/>
+          <a:lstStyle/>
+          <a:p>
+            <a:pPr algn="ctr"/>
+          </a:p>
+        </p:txBody>
+      </p:sp>
+      <p:sp>
+        <p:nvSpPr>
+          <p:cNvPr id="15" name="TextBox 14"/>
+          <p:cNvSpPr txBox="1"/>
+          <p:nvPr/>
+        </p:nvSpPr>
+        <p:spPr>
+          <a:xfrm>
+            <a:off x="6309359" y="1271016"/>
+            <a:ext cx="5486400" cy="347472"/>
+          </a:xfrm>
+          <a:prstGeom prst="rect">
+            <a:avLst/>
+          </a:prstGeom>
+          <a:noFill/>
+        </p:spPr>
+        <p:txBody>
+          <a:bodyPr wrap="square">
+            <a:spAutoFit/>
+          </a:bodyPr>
+          <a:lstStyle/>
+          <a:p>
+            <a:pPr algn="l"/>
+            <a:r>
+              <a:rPr sz="1300" b="1" i="0">
+                <a:solidFill>
+                  <a:srgbClr val="FFFFFF"/>
+                </a:solidFill>
+              </a:rPr>
+              <a:t>2. Transposition PK NHP → Humain</a:t>
+            </a:r>
+          </a:p>
+        </p:txBody>
+      </p:sp>
+      <p:sp>
+        <p:nvSpPr>
+          <p:cNvPr id="16" name="TextBox 15"/>
+          <p:cNvSpPr txBox="1"/>
+          <p:nvPr/>
+        </p:nvSpPr>
+        <p:spPr>
+          <a:xfrm>
+            <a:off x="6355080" y="1709928"/>
+            <a:ext cx="5394960" cy="530352"/>
+          </a:xfrm>
+          <a:prstGeom prst="rect">
+            <a:avLst/>
+          </a:prstGeom>
+          <a:noFill/>
+        </p:spPr>
+        <p:txBody>
+          <a:bodyPr wrap="square">
+            <a:spAutoFit/>
+          </a:bodyPr>
+          <a:lstStyle/>
+          <a:p>
+            <a:pPr algn="l"/>
+            <a:r>
+              <a:rPr sz="1150" b="0" i="0">
+                <a:solidFill>
+                  <a:srgbClr val="1A1A1A"/>
+                </a:solidFill>
+              </a:rPr>
+              <a:t>▸ Allométrie standard : CL_hum = CL_NHP × (70/BW_NHP)⁰·⁷⁵</a:t>
+            </a:r>
+          </a:p>
+        </p:txBody>
+      </p:sp>
+      <p:sp>
+        <p:nvSpPr>
+          <p:cNvPr id="17" name="TextBox 16"/>
+          <p:cNvSpPr txBox="1"/>
+          <p:nvPr/>
+        </p:nvSpPr>
+        <p:spPr>
+          <a:xfrm>
+            <a:off x="6355080" y="2276856"/>
+            <a:ext cx="5394960" cy="530352"/>
+          </a:xfrm>
+          <a:prstGeom prst="rect">
+            <a:avLst/>
+          </a:prstGeom>
+          <a:noFill/>
+        </p:spPr>
+        <p:txBody>
+          <a:bodyPr wrap="square">
+            <a:spAutoFit/>
+          </a:bodyPr>
+          <a:lstStyle/>
+          <a:p>
+            <a:pPr algn="l"/>
+            <a:r>
+              <a:rPr sz="1150" b="0" i="0">
+                <a:solidFill>
+                  <a:srgbClr val="1A1A1A"/>
+                </a:solidFill>
+              </a:rPr>
+              <a:t>▸ Validée sur T-DXd (facteur erreur &lt; 2 sur CL)</a:t>
+            </a:r>
+          </a:p>
+        </p:txBody>
+      </p:sp>
+      <p:sp>
+        <p:nvSpPr>
+          <p:cNvPr id="18" name="TextBox 17"/>
+          <p:cNvSpPr txBox="1"/>
+          <p:nvPr/>
+        </p:nvSpPr>
+        <p:spPr>
+          <a:xfrm>
+            <a:off x="6355080" y="2843784"/>
+            <a:ext cx="5394960" cy="530352"/>
+          </a:xfrm>
+          <a:prstGeom prst="rect">
+            <a:avLst/>
+          </a:prstGeom>
+          <a:noFill/>
+        </p:spPr>
+        <p:txBody>
+          <a:bodyPr wrap="square">
+            <a:spAutoFit/>
+          </a:bodyPr>
+          <a:lstStyle/>
+          <a:p>
+            <a:pPr algn="l"/>
+            <a:r>
+              <a:rPr sz="1150" b="0" i="0">
+                <a:solidFill>
+                  <a:srgbClr val="1A1A1A"/>
+                </a:solidFill>
+              </a:rPr>
+              <a:t>▸ Générer les paramètres PK humains de départ</a:t>
+            </a:r>
+          </a:p>
+        </p:txBody>
+      </p:sp>
+      <p:sp>
+        <p:nvSpPr>
+          <p:cNvPr id="19" name="Rectangle 18"/>
+          <p:cNvSpPr/>
+          <p:nvPr/>
+        </p:nvSpPr>
+        <p:spPr>
+          <a:xfrm>
+            <a:off x="274320" y="3840480"/>
+            <a:ext cx="5669280" cy="2423160"/>
+          </a:xfrm>
+          <a:prstGeom prst="rect">
+            <a:avLst/>
+          </a:prstGeom>
+          <a:solidFill>
+            <a:srgbClr val="FFFFFF"/>
+          </a:solidFill>
+          <a:ln w="31750">
+            <a:solidFill>
+              <a:srgbClr val="C5501A"/>
+            </a:solidFill>
+          </a:ln>
+        </p:spPr>
+        <p:style>
+          <a:lnRef idx="1">
+            <a:schemeClr val="accent1"/>
+          </a:lnRef>
+          <a:fillRef idx="3">
+            <a:schemeClr val="accent1"/>
+          </a:fillRef>
+          <a:effectRef idx="2">
+            <a:schemeClr val="accent1"/>
+          </a:effectRef>
+          <a:fontRef idx="minor">
+            <a:schemeClr val="lt1"/>
+          </a:fontRef>
+        </p:style>
+        <p:txBody>
+          <a:bodyPr rtlCol="0" anchor="ctr"/>
+          <a:lstStyle/>
+          <a:p>
+            <a:pPr algn="ctr"/>
+          </a:p>
+        </p:txBody>
+      </p:sp>
+      <p:sp>
+        <p:nvSpPr>
+          <p:cNvPr id="20" name="Rectangle 19"/>
+          <p:cNvSpPr/>
+          <p:nvPr/>
+        </p:nvSpPr>
+        <p:spPr>
+          <a:xfrm>
+            <a:off x="274320" y="3840480"/>
+            <a:ext cx="5669280" cy="411480"/>
+          </a:xfrm>
+          <a:prstGeom prst="rect">
+            <a:avLst/>
+          </a:prstGeom>
+          <a:solidFill>
+            <a:srgbClr val="C5501A"/>
+          </a:solidFill>
+          <a:ln w="19050">
+            <a:noFill/>
+          </a:ln>
+        </p:spPr>
+        <p:style>
+          <a:lnRef idx="1">
+            <a:schemeClr val="accent1"/>
+          </a:lnRef>
+          <a:fillRef idx="3">
+            <a:schemeClr val="accent1"/>
+          </a:fillRef>
+          <a:effectRef idx="2">
+            <a:schemeClr val="accent1"/>
+          </a:effectRef>
+          <a:fontRef idx="minor">
+            <a:schemeClr val="lt1"/>
+          </a:fontRef>
+        </p:style>
+        <p:txBody>
+          <a:bodyPr rtlCol="0" anchor="ctr"/>
+          <a:lstStyle/>
+          <a:p>
+            <a:pPr algn="ctr"/>
+          </a:p>
+        </p:txBody>
+      </p:sp>
+      <p:sp>
+        <p:nvSpPr>
+          <p:cNvPr id="21" name="TextBox 20"/>
+          <p:cNvSpPr txBox="1"/>
+          <p:nvPr/>
+        </p:nvSpPr>
+        <p:spPr>
+          <a:xfrm>
+            <a:off x="365760" y="3877056"/>
+            <a:ext cx="5486400" cy="347472"/>
+          </a:xfrm>
+          <a:prstGeom prst="rect">
+            <a:avLst/>
+          </a:prstGeom>
+          <a:noFill/>
+        </p:spPr>
+        <p:txBody>
+          <a:bodyPr wrap="square">
+            <a:spAutoFit/>
+          </a:bodyPr>
+          <a:lstStyle/>
+          <a:p>
+            <a:pPr algn="l"/>
+            <a:r>
+              <a:rPr sz="1300" b="1" i="0">
+                <a:solidFill>
+                  <a:srgbClr val="FFFFFF"/>
+                </a:solidFill>
+              </a:rPr>
+              <a:t>3. Simulation de la toxicité humaine attendue</a:t>
+            </a:r>
+          </a:p>
+        </p:txBody>
+      </p:sp>
+      <p:sp>
+        <p:nvSpPr>
+          <p:cNvPr id="22" name="TextBox 21"/>
+          <p:cNvSpPr txBox="1"/>
+          <p:nvPr/>
+        </p:nvSpPr>
+        <p:spPr>
+          <a:xfrm>
+            <a:off x="411479" y="4315968"/>
+            <a:ext cx="5394960" cy="530352"/>
+          </a:xfrm>
+          <a:prstGeom prst="rect">
+            <a:avLst/>
+          </a:prstGeom>
+          <a:noFill/>
+        </p:spPr>
+        <p:txBody>
+          <a:bodyPr wrap="square">
+            <a:spAutoFit/>
+          </a:bodyPr>
+          <a:lstStyle/>
+          <a:p>
+            <a:pPr algn="l"/>
+            <a:r>
+              <a:rPr sz="1150" b="0" i="0">
+                <a:solidFill>
+                  <a:srgbClr val="1A1A1A"/>
+                </a:solidFill>
+              </a:rPr>
+              <a:t>▸ Utiliser les Slopes NHP comme estimation initiale chez l'humain</a:t>
+            </a:r>
+          </a:p>
+        </p:txBody>
+      </p:sp>
+      <p:sp>
+        <p:nvSpPr>
+          <p:cNvPr id="23" name="TextBox 22"/>
+          <p:cNvSpPr txBox="1"/>
+          <p:nvPr/>
+        </p:nvSpPr>
+        <p:spPr>
+          <a:xfrm>
+            <a:off x="411479" y="4882896"/>
+            <a:ext cx="5394960" cy="530352"/>
+          </a:xfrm>
+          <a:prstGeom prst="rect">
+            <a:avLst/>
+          </a:prstGeom>
+          <a:noFill/>
+        </p:spPr>
+        <p:txBody>
+          <a:bodyPr wrap="square">
+            <a:spAutoFit/>
+          </a:bodyPr>
+          <a:lstStyle/>
+          <a:p>
+            <a:pPr algn="l"/>
+            <a:r>
+              <a:rPr sz="1150" b="0" i="0">
+                <a:solidFill>
+                  <a:srgbClr val="1A1A1A"/>
+                </a:solidFill>
+              </a:rPr>
+              <a:t>▸ Simuler N=300 patients virtuels (IIV log-normal)</a:t>
+            </a:r>
+          </a:p>
+        </p:txBody>
+      </p:sp>
+      <p:sp>
+        <p:nvSpPr>
+          <p:cNvPr id="24" name="TextBox 23"/>
+          <p:cNvSpPr txBox="1"/>
+          <p:nvPr/>
+        </p:nvSpPr>
+        <p:spPr>
+          <a:xfrm>
+            <a:off x="411479" y="5449824"/>
+            <a:ext cx="5394960" cy="530352"/>
+          </a:xfrm>
+          <a:prstGeom prst="rect">
+            <a:avLst/>
+          </a:prstGeom>
+          <a:noFill/>
+        </p:spPr>
+        <p:txBody>
+          <a:bodyPr wrap="square">
+            <a:spAutoFit/>
+          </a:bodyPr>
+          <a:lstStyle/>
+          <a:p>
+            <a:pPr algn="l"/>
+            <a:r>
+              <a:rPr sz="1150" b="0" i="0">
+                <a:solidFill>
+                  <a:srgbClr val="1A1A1A"/>
+                </a:solidFill>
+              </a:rPr>
+              <a:t>▸ Prédire la distribution des grades CTCAE v5 à différentes doses FIH</a:t>
+            </a:r>
+          </a:p>
+        </p:txBody>
+      </p:sp>
+      <p:sp>
+        <p:nvSpPr>
+          <p:cNvPr id="25" name="Rectangle 24"/>
+          <p:cNvSpPr/>
+          <p:nvPr/>
+        </p:nvSpPr>
+        <p:spPr>
+          <a:xfrm>
+            <a:off x="6217920" y="3840480"/>
+            <a:ext cx="5669280" cy="2423160"/>
+          </a:xfrm>
+          <a:prstGeom prst="rect">
+            <a:avLst/>
+          </a:prstGeom>
+          <a:solidFill>
+            <a:srgbClr val="FFFFFF"/>
+          </a:solidFill>
+          <a:ln w="31750">
+            <a:solidFill>
+              <a:srgbClr val="60328A"/>
+            </a:solidFill>
+          </a:ln>
+        </p:spPr>
+        <p:style>
+          <a:lnRef idx="1">
+            <a:schemeClr val="accent1"/>
+          </a:lnRef>
+          <a:fillRef idx="3">
+            <a:schemeClr val="accent1"/>
+          </a:fillRef>
+          <a:effectRef idx="2">
+            <a:schemeClr val="accent1"/>
+          </a:effectRef>
+          <a:fontRef idx="minor">
+            <a:schemeClr val="lt1"/>
+          </a:fontRef>
+        </p:style>
+        <p:txBody>
+          <a:bodyPr rtlCol="0" anchor="ctr"/>
+          <a:lstStyle/>
+          <a:p>
+            <a:pPr algn="ctr"/>
+          </a:p>
+        </p:txBody>
+      </p:sp>
+      <p:sp>
+        <p:nvSpPr>
+          <p:cNvPr id="26" name="Rectangle 25"/>
+          <p:cNvSpPr/>
+          <p:nvPr/>
+        </p:nvSpPr>
+        <p:spPr>
+          <a:xfrm>
+            <a:off x="6217920" y="3840480"/>
+            <a:ext cx="5669280" cy="411480"/>
+          </a:xfrm>
+          <a:prstGeom prst="rect">
+            <a:avLst/>
+          </a:prstGeom>
+          <a:solidFill>
+            <a:srgbClr val="60328A"/>
+          </a:solidFill>
+          <a:ln w="19050">
+            <a:noFill/>
+          </a:ln>
+        </p:spPr>
+        <p:style>
+          <a:lnRef idx="1">
+            <a:schemeClr val="accent1"/>
+          </a:lnRef>
+          <a:fillRef idx="3">
+            <a:schemeClr val="accent1"/>
+          </a:fillRef>
+          <a:effectRef idx="2">
+            <a:schemeClr val="accent1"/>
+          </a:effectRef>
+          <a:fontRef idx="minor">
+            <a:schemeClr val="lt1"/>
+          </a:fontRef>
+        </p:style>
+        <p:txBody>
+          <a:bodyPr rtlCol="0" anchor="ctr"/>
+          <a:lstStyle/>
+          <a:p>
+            <a:pPr algn="ctr"/>
+          </a:p>
+        </p:txBody>
+      </p:sp>
+      <p:sp>
+        <p:nvSpPr>
+          <p:cNvPr id="27" name="TextBox 26"/>
+          <p:cNvSpPr txBox="1"/>
+          <p:nvPr/>
+        </p:nvSpPr>
+        <p:spPr>
+          <a:xfrm>
+            <a:off x="6309359" y="3877056"/>
+            <a:ext cx="5486400" cy="347472"/>
+          </a:xfrm>
+          <a:prstGeom prst="rect">
+            <a:avLst/>
+          </a:prstGeom>
+          <a:noFill/>
+        </p:spPr>
+        <p:txBody>
+          <a:bodyPr wrap="square">
+            <a:spAutoFit/>
+          </a:bodyPr>
+          <a:lstStyle/>
+          <a:p>
+            <a:pPr algn="l"/>
+            <a:r>
+              <a:rPr sz="1300" b="1" i="0">
+                <a:solidFill>
+                  <a:srgbClr val="FFFFFF"/>
+                </a:solidFill>
+              </a:rPr>
+              <a:t>4. Support à la dose de départ FIH</a:t>
+            </a:r>
+          </a:p>
+        </p:txBody>
+      </p:sp>
+      <p:sp>
+        <p:nvSpPr>
+          <p:cNvPr id="28" name="TextBox 27"/>
+          <p:cNvSpPr txBox="1"/>
+          <p:nvPr/>
+        </p:nvSpPr>
+        <p:spPr>
+          <a:xfrm>
+            <a:off x="6355080" y="4315968"/>
+            <a:ext cx="5394960" cy="530352"/>
+          </a:xfrm>
+          <a:prstGeom prst="rect">
+            <a:avLst/>
+          </a:prstGeom>
+          <a:noFill/>
+        </p:spPr>
+        <p:txBody>
+          <a:bodyPr wrap="square">
+            <a:spAutoFit/>
+          </a:bodyPr>
+          <a:lstStyle/>
+          <a:p>
+            <a:pPr algn="l"/>
+            <a:r>
+              <a:rPr sz="1150" b="0" i="0">
+                <a:solidFill>
+                  <a:srgbClr val="1A1A1A"/>
+                </a:solidFill>
+              </a:rPr>
+              <a:t>▸ Identifier la dose associée à P(G≥3) &lt; 10%</a:t>
+            </a:r>
+          </a:p>
+        </p:txBody>
+      </p:sp>
+      <p:sp>
+        <p:nvSpPr>
+          <p:cNvPr id="29" name="TextBox 28"/>
+          <p:cNvSpPr txBox="1"/>
+          <p:nvPr/>
+        </p:nvSpPr>
+        <p:spPr>
+          <a:xfrm>
+            <a:off x="6355080" y="4882896"/>
+            <a:ext cx="5394960" cy="530352"/>
+          </a:xfrm>
+          <a:prstGeom prst="rect">
+            <a:avLst/>
+          </a:prstGeom>
+          <a:noFill/>
+        </p:spPr>
+        <p:txBody>
+          <a:bodyPr wrap="square">
+            <a:spAutoFit/>
+          </a:bodyPr>
+          <a:lstStyle/>
+          <a:p>
+            <a:pPr algn="l"/>
+            <a:r>
+              <a:rPr sz="1150" b="0" i="0">
+                <a:solidFill>
+                  <a:srgbClr val="1A1A1A"/>
+                </a:solidFill>
+              </a:rPr>
+              <a:t>▸ Intégrer le NOAEL NHP comme contrainte de sécurité</a:t>
+            </a:r>
+          </a:p>
+        </p:txBody>
+      </p:sp>
+      <p:sp>
+        <p:nvSpPr>
+          <p:cNvPr id="30" name="TextBox 29"/>
+          <p:cNvSpPr txBox="1"/>
+          <p:nvPr/>
+        </p:nvSpPr>
+        <p:spPr>
+          <a:xfrm>
+            <a:off x="6355080" y="5449824"/>
+            <a:ext cx="5394960" cy="530352"/>
+          </a:xfrm>
+          <a:prstGeom prst="rect">
+            <a:avLst/>
+          </a:prstGeom>
+          <a:noFill/>
+        </p:spPr>
+        <p:txBody>
+          <a:bodyPr wrap="square">
+            <a:spAutoFit/>
+          </a:bodyPr>
+          <a:lstStyle/>
+          <a:p>
+            <a:pPr algn="l"/>
+            <a:r>
+              <a:rPr sz="1150" b="0" i="0">
+                <a:solidFill>
+                  <a:srgbClr val="1A1A1A"/>
+                </a:solidFill>
+              </a:rPr>
+              <a:t>▸ Documenter pour le dossier IND/CTA (FDA/EMA)</a:t>
+            </a:r>
+          </a:p>
+        </p:txBody>
+      </p:sp>
+    </p:spTree>
+  </p:cSld>
+  <p:clrMapOvr>
+    <a:masterClrMapping/>
+  </p:clrMapOvr>
+</p:sld>
+</file>
+
+<file path=ppt/slides/slide8.xml><?xml version="1.0" encoding="utf-8"?>
 <p:sld xmlns:a="http://schemas.openxmlformats.org/drawingml/2006/main" xmlns:p="http://schemas.openxmlformats.org/presentationml/2006/main" xmlns:r="http://schemas.openxmlformats.org/officeDocument/2006/relationships">
   <p:cSld>
     <p:spTree>

</xml_diff>